<commit_message>
docs: atualiza relatório, slides e contexto com busca híbrida — sanções resolvidas, TOP_K=6, BM25+semântico documentados
</commit_message>
<xml_diff>
--- a/relatorio/slides_lgpd_rag.pptx
+++ b/relatorio/slides_lgpd_rag.pptx
@@ -6576,11 +6576,11 @@
             <a:avLst/>
           </a:prstGeom>
           <a:solidFill>
-            <a:srgbClr val="FDF2E3"/>
+            <a:srgbClr val="E9F7EF"/>
           </a:solidFill>
           <a:ln w="12700">
             <a:solidFill>
-              <a:srgbClr val="F39C12"/>
+              <a:srgbClr val="27AE60"/>
             </a:solidFill>
           </a:ln>
         </p:spPr>
@@ -6632,10 +6632,10 @@
             <a:r>
               <a:rPr sz="1400" b="0" i="0">
                 <a:solidFill>
-                  <a:srgbClr val="7D4A00"/>
-                </a:solidFill>
-              </a:rPr>
-              <a:t>⚠️  Limitação residual: sanções do Art. 52 ainda falham (chunks na posição 9+ do ranking global). Solução definitiva: hybrid search (BM25 + semântico).</a:t>
+                  <a:srgbClr val="1A6B3A"/>
+                </a:solidFill>
+              </a:rPr>
+              <a:t>✅  Sanções resolvidas com busca híbrida (BM25 + semântico, pool 150): "Quais sanções a ANPD pode aplicar?" → base_suficiente=true, confiança 100%.</a:t>
             </a:r>
           </a:p>
         </p:txBody>
@@ -14391,7 +14391,7 @@
                   <a:srgbClr val="FFFFFF"/>
                 </a:solidFill>
               </a:rPr>
-              <a:t>Recuperação vetorial</a:t>
+              <a:t>Recuperação híbrida (BM25 + semântico)</a:t>
             </a:r>
           </a:p>
         </p:txBody>
@@ -14404,8 +14404,8 @@
         </p:nvSpPr>
         <p:spPr>
           <a:xfrm>
-            <a:off x="457200" y="1005840"/>
-            <a:ext cx="3383280" cy="822960"/>
+            <a:off x="365760" y="1005840"/>
+            <a:ext cx="2560320" cy="777240"/>
           </a:xfrm>
           <a:prstGeom prst="rect">
             <a:avLst/>
@@ -14447,8 +14447,8 @@
         </p:nvSpPr>
         <p:spPr>
           <a:xfrm>
-            <a:off x="457200" y="1051560"/>
-            <a:ext cx="3383280" cy="777240"/>
+            <a:off x="365760" y="1051560"/>
+            <a:ext cx="2560320" cy="731520"/>
           </a:xfrm>
           <a:prstGeom prst="rect">
             <a:avLst/>
@@ -14463,13 +14463,13 @@
           <a:p>
             <a:pPr algn="ctr"/>
             <a:r>
-              <a:rPr sz="1600" b="1" i="0">
+              <a:rPr sz="1500" b="1" i="0">
                 <a:solidFill>
                   <a:srgbClr val="FFFFFF"/>
                 </a:solidFill>
               </a:rPr>
               <a:t>Pergunta
-→ vetor SBERT</a:t>
+→ SBERT</a:t>
             </a:r>
           </a:p>
         </p:txBody>
@@ -14482,8 +14482,8 @@
         </p:nvSpPr>
         <p:spPr>
           <a:xfrm>
-            <a:off x="3840480" y="1234440"/>
-            <a:ext cx="365760" cy="365760"/>
+            <a:off x="2926080" y="1234440"/>
+            <a:ext cx="182880" cy="320040"/>
           </a:xfrm>
           <a:prstGeom prst="rect">
             <a:avLst/>
@@ -14498,7 +14498,7 @@
           <a:p>
             <a:pPr algn="l"/>
             <a:r>
-              <a:rPr sz="2000" b="1" i="0">
+              <a:rPr sz="1800" b="1" i="0">
                 <a:solidFill>
                   <a:srgbClr val="3D9BE8"/>
                 </a:solidFill>
@@ -14516,8 +14516,8 @@
         </p:nvSpPr>
         <p:spPr>
           <a:xfrm>
-            <a:off x="4206240" y="1005840"/>
-            <a:ext cx="3383280" cy="822960"/>
+            <a:off x="3291840" y="1005840"/>
+            <a:ext cx="2560320" cy="777240"/>
           </a:xfrm>
           <a:prstGeom prst="rect">
             <a:avLst/>
@@ -14559,8 +14559,8 @@
         </p:nvSpPr>
         <p:spPr>
           <a:xfrm>
-            <a:off x="4206240" y="1051560"/>
-            <a:ext cx="3383280" cy="777240"/>
+            <a:off x="3291840" y="1051560"/>
+            <a:ext cx="2560320" cy="731520"/>
           </a:xfrm>
           <a:prstGeom prst="rect">
             <a:avLst/>
@@ -14575,13 +14575,13 @@
           <a:p>
             <a:pPr algn="ctr"/>
             <a:r>
-              <a:rPr sz="1600" b="1" i="0">
+              <a:rPr sz="1500" b="1" i="0">
                 <a:solidFill>
                   <a:srgbClr val="FFFFFF"/>
                 </a:solidFill>
               </a:rPr>
-              <a:t>Chroma
-cosine similarity</a:t>
+              <a:t>150 candidatos
+Chroma cosine</a:t>
             </a:r>
           </a:p>
         </p:txBody>
@@ -14594,8 +14594,8 @@
         </p:nvSpPr>
         <p:spPr>
           <a:xfrm>
-            <a:off x="7589520" y="1234440"/>
-            <a:ext cx="365760" cy="365760"/>
+            <a:off x="5852160" y="1234440"/>
+            <a:ext cx="182880" cy="320040"/>
           </a:xfrm>
           <a:prstGeom prst="rect">
             <a:avLst/>
@@ -14610,7 +14610,7 @@
           <a:p>
             <a:pPr algn="l"/>
             <a:r>
-              <a:rPr sz="2000" b="1" i="0">
+              <a:rPr sz="1800" b="1" i="0">
                 <a:solidFill>
                   <a:srgbClr val="3D9BE8"/>
                 </a:solidFill>
@@ -14628,8 +14628,120 @@
         </p:nvSpPr>
         <p:spPr>
           <a:xfrm>
-            <a:off x="7955279" y="1005840"/>
-            <a:ext cx="3383280" cy="822960"/>
+            <a:off x="6217920" y="1005840"/>
+            <a:ext cx="2560320" cy="777240"/>
+          </a:xfrm>
+          <a:prstGeom prst="rect">
+            <a:avLst/>
+          </a:prstGeom>
+          <a:solidFill>
+            <a:srgbClr val="1A6BA8"/>
+          </a:solidFill>
+          <a:ln>
+            <a:noFill/>
+          </a:ln>
+        </p:spPr>
+        <p:style>
+          <a:lnRef idx="1">
+            <a:schemeClr val="accent1"/>
+          </a:lnRef>
+          <a:fillRef idx="3">
+            <a:schemeClr val="accent1"/>
+          </a:fillRef>
+          <a:effectRef idx="2">
+            <a:schemeClr val="accent1"/>
+          </a:effectRef>
+          <a:fontRef idx="minor">
+            <a:schemeClr val="lt1"/>
+          </a:fontRef>
+        </p:style>
+        <p:txBody>
+          <a:bodyPr rtlCol="0" anchor="ctr"/>
+          <a:lstStyle/>
+          <a:p>
+            <a:pPr algn="ctr"/>
+          </a:p>
+        </p:txBody>
+      </p:sp>
+      <p:sp>
+        <p:nvSpPr>
+          <p:cNvPr id="12" name="TextBox 11"/>
+          <p:cNvSpPr txBox="1"/>
+          <p:nvPr/>
+        </p:nvSpPr>
+        <p:spPr>
+          <a:xfrm>
+            <a:off x="6217920" y="1051560"/>
+            <a:ext cx="2560320" cy="731520"/>
+          </a:xfrm>
+          <a:prstGeom prst="rect">
+            <a:avLst/>
+          </a:prstGeom>
+          <a:noFill/>
+        </p:spPr>
+        <p:txBody>
+          <a:bodyPr wrap="square">
+            <a:spAutoFit/>
+          </a:bodyPr>
+          <a:lstStyle/>
+          <a:p>
+            <a:pPr algn="ctr"/>
+            <a:r>
+              <a:rPr sz="1500" b="1" i="0">
+                <a:solidFill>
+                  <a:srgbClr val="FFFFFF"/>
+                </a:solidFill>
+              </a:rPr>
+              <a:t>BM25
+keywords</a:t>
+            </a:r>
+          </a:p>
+        </p:txBody>
+      </p:sp>
+      <p:sp>
+        <p:nvSpPr>
+          <p:cNvPr id="13" name="TextBox 12"/>
+          <p:cNvSpPr txBox="1"/>
+          <p:nvPr/>
+        </p:nvSpPr>
+        <p:spPr>
+          <a:xfrm>
+            <a:off x="8778240" y="1234440"/>
+            <a:ext cx="182880" cy="320040"/>
+          </a:xfrm>
+          <a:prstGeom prst="rect">
+            <a:avLst/>
+          </a:prstGeom>
+          <a:noFill/>
+        </p:spPr>
+        <p:txBody>
+          <a:bodyPr wrap="square">
+            <a:spAutoFit/>
+          </a:bodyPr>
+          <a:lstStyle/>
+          <a:p>
+            <a:pPr algn="l"/>
+            <a:r>
+              <a:rPr sz="1800" b="1" i="0">
+                <a:solidFill>
+                  <a:srgbClr val="3D9BE8"/>
+                </a:solidFill>
+              </a:rPr>
+              <a:t>→</a:t>
+            </a:r>
+          </a:p>
+        </p:txBody>
+      </p:sp>
+      <p:sp>
+        <p:nvSpPr>
+          <p:cNvPr id="14" name="Rectangle 13"/>
+          <p:cNvSpPr/>
+          <p:nvPr/>
+        </p:nvSpPr>
+        <p:spPr>
+          <a:xfrm>
+            <a:off x="9144000" y="1005840"/>
+            <a:ext cx="2560320" cy="777240"/>
           </a:xfrm>
           <a:prstGeom prst="rect">
             <a:avLst/>
@@ -14665,14 +14777,14 @@
       </p:sp>
       <p:sp>
         <p:nvSpPr>
-          <p:cNvPr id="12" name="TextBox 11"/>
+          <p:cNvPr id="15" name="TextBox 14"/>
           <p:cNvSpPr txBox="1"/>
           <p:nvPr/>
         </p:nvSpPr>
         <p:spPr>
           <a:xfrm>
-            <a:off x="7955279" y="1051560"/>
-            <a:ext cx="3383280" cy="777240"/>
+            <a:off x="9144000" y="1051560"/>
+            <a:ext cx="2560320" cy="731520"/>
           </a:xfrm>
           <a:prstGeom prst="rect">
             <a:avLst/>
@@ -14687,27 +14799,70 @@
           <a:p>
             <a:pPr algn="ctr"/>
             <a:r>
-              <a:rPr sz="1600" b="1" i="0">
+              <a:rPr sz="1500" b="1" i="0">
                 <a:solidFill>
                   <a:srgbClr val="FFFFFF"/>
                 </a:solidFill>
               </a:rPr>
-              <a:t>top-k chunks
-mais próximos</a:t>
-            </a:r>
-          </a:p>
-        </p:txBody>
-      </p:sp>
-      <p:sp>
-        <p:nvSpPr>
-          <p:cNvPr id="13" name="TextBox 12"/>
+              <a:t>Re-rank
+top-6</a:t>
+            </a:r>
+          </a:p>
+        </p:txBody>
+      </p:sp>
+      <p:sp>
+        <p:nvSpPr>
+          <p:cNvPr id="16" name="Rectangle 15"/>
+          <p:cNvSpPr/>
+          <p:nvPr/>
+        </p:nvSpPr>
+        <p:spPr>
+          <a:xfrm>
+            <a:off x="457200" y="1965960"/>
+            <a:ext cx="11247120" cy="502920"/>
+          </a:xfrm>
+          <a:prstGeom prst="rect">
+            <a:avLst/>
+          </a:prstGeom>
+          <a:solidFill>
+            <a:srgbClr val="143A5C"/>
+          </a:solidFill>
+          <a:ln>
+            <a:noFill/>
+          </a:ln>
+        </p:spPr>
+        <p:style>
+          <a:lnRef idx="1">
+            <a:schemeClr val="accent1"/>
+          </a:lnRef>
+          <a:fillRef idx="3">
+            <a:schemeClr val="accent1"/>
+          </a:fillRef>
+          <a:effectRef idx="2">
+            <a:schemeClr val="accent1"/>
+          </a:effectRef>
+          <a:fontRef idx="minor">
+            <a:schemeClr val="lt1"/>
+          </a:fontRef>
+        </p:style>
+        <p:txBody>
+          <a:bodyPr rtlCol="0" anchor="ctr"/>
+          <a:lstStyle/>
+          <a:p>
+            <a:pPr algn="ctr"/>
+          </a:p>
+        </p:txBody>
+      </p:sp>
+      <p:sp>
+        <p:nvSpPr>
+          <p:cNvPr id="17" name="TextBox 16"/>
           <p:cNvSpPr txBox="1"/>
           <p:nvPr/>
         </p:nvSpPr>
         <p:spPr>
           <a:xfrm>
-            <a:off x="457200" y="2011680"/>
-            <a:ext cx="11247120" cy="4663440"/>
+            <a:off x="594360" y="2029968"/>
+            <a:ext cx="10972800" cy="365760"/>
           </a:xfrm>
           <a:prstGeom prst="rect">
             <a:avLst/>
@@ -14720,57 +14875,78 @@
           </a:bodyPr>
           <a:lstStyle/>
           <a:p>
+            <a:pPr algn="ctr"/>
+            <a:r>
+              <a:rPr sz="1500" b="1" i="0">
+                <a:solidFill>
+                  <a:srgbClr val="3D9BE8"/>
+                </a:solidFill>
+              </a:rPr>
+              <a:t>hybrid = 0,85 × semântico + 0,15 × BM25   |   score &lt; 0,22 → recusa antes do LLM</a:t>
+            </a:r>
+          </a:p>
+        </p:txBody>
+      </p:sp>
+      <p:sp>
+        <p:nvSpPr>
+          <p:cNvPr id="18" name="TextBox 17"/>
+          <p:cNvSpPr txBox="1"/>
+          <p:nvPr/>
+        </p:nvSpPr>
+        <p:spPr>
+          <a:xfrm>
+            <a:off x="457200" y="2651760"/>
+            <a:ext cx="11247120" cy="4023360"/>
+          </a:xfrm>
+          <a:prstGeom prst="rect">
+            <a:avLst/>
+          </a:prstGeom>
+          <a:noFill/>
+        </p:spPr>
+        <p:txBody>
+          <a:bodyPr wrap="square">
+            <a:spAutoFit/>
+          </a:bodyPr>
+          <a:lstStyle/>
+          <a:p>
             <a:pPr/>
             <a:r>
+              <a:rPr sz="1700" b="1">
+                <a:solidFill>
+                  <a:srgbClr val="2C3E50"/>
+                </a:solidFill>
+              </a:rPr>
+              <a:t>Por que híbrido?</a:t>
+            </a:r>
+            <a:r>
               <a:rPr sz="1700" b="0">
                 <a:solidFill>
                   <a:srgbClr val="2C3E50"/>
                 </a:solidFill>
               </a:rPr>
-              <a:t>A pergunta é vetorizada pelo </a:t>
-            </a:r>
-            <a:r>
-              <a:rPr sz="1700" b="1">
+              <a:t> Semântico puro falha em termos jurídicos específicos</a:t>
+            </a:r>
+          </a:p>
+          <a:p>
+            <a:pPr lvl="1"/>
+            <a:r>
+              <a:rPr sz="1600" b="0">
                 <a:solidFill>
                   <a:srgbClr val="2C3E50"/>
                 </a:solidFill>
               </a:rPr>
-              <a:t>mesmo modelo</a:t>
-            </a:r>
-            <a:r>
-              <a:rPr sz="1700" b="0">
+              <a:t>Ex: "sanções a ANPD" → BM25 detecta "sanções", "aplicar" nos chunks da Resolução 4/2023</a:t>
+            </a:r>
+          </a:p>
+          <a:p>
+            <a:pPr lvl="1"/>
+            <a:r>
+              <a:rPr sz="1600" b="0">
                 <a:solidFill>
                   <a:srgbClr val="2C3E50"/>
                 </a:solidFill>
               </a:rPr>
-              <a:t> de embedding (384 dim)</a:t>
-            </a:r>
-          </a:p>
-          <a:p>
-            <a:pPr/>
-            <a:r>
-              <a:rPr sz="1700" b="0">
-                <a:solidFill>
-                  <a:srgbClr val="2C3E50"/>
-                </a:solidFill>
-              </a:rPr>
-              <a:t>Chroma usa </a:t>
-            </a:r>
-            <a:r>
-              <a:rPr sz="1700" b="1">
-                <a:solidFill>
-                  <a:srgbClr val="2C3E50"/>
-                </a:solidFill>
-              </a:rPr>
-              <a:t>cosine similarity</a:t>
-            </a:r>
-            <a:r>
-              <a:rPr sz="1700" b="0">
-                <a:solidFill>
-                  <a:srgbClr val="2C3E50"/>
-                </a:solidFill>
-              </a:rPr>
-              <a:t> — `score = 1 − (distância / 2)`</a:t>
+              <a:t>Com semântico puro: chunk correto na posição 9+ · Com híbrido: top-3 ✅</a:t>
             </a:r>
           </a:p>
           <a:p>
@@ -14788,7 +14964,7 @@
                   <a:srgbClr val="2C3E50"/>
                 </a:solidFill>
               </a:rPr>
-              <a:t>Threshold MIN_SCORE = 0,3:</a:t>
+              <a:t>Pool de 150 candidatos</a:t>
             </a:r>
             <a:r>
               <a:rPr sz="1700" b="0">
@@ -14796,15 +14972,18 @@
                   <a:srgbClr val="2C3E50"/>
                 </a:solidFill>
               </a:rPr>
-              <a:t> score abaixo → recusa </a:t>
-            </a:r>
+              <a:t> garante que o chunk certo esteja disponível para re-ranking</a:t>
+            </a:r>
+          </a:p>
+          <a:p>
+            <a:pPr/>
             <a:r>
               <a:rPr sz="1700" b="1">
                 <a:solidFill>
                   <a:srgbClr val="2C3E50"/>
                 </a:solidFill>
               </a:rPr>
-              <a:t>antes</a:t>
+              <a:t>α=0,85</a:t>
             </a:r>
             <a:r>
               <a:rPr sz="1700" b="0">
@@ -14812,73 +14991,26 @@
                   <a:srgbClr val="2C3E50"/>
                 </a:solidFill>
               </a:rPr>
-              <a:t> de chamar o LLM</a:t>
-            </a:r>
-          </a:p>
-          <a:p>
-            <a:pPr lvl="1"/>
-            <a:r>
-              <a:rPr sz="1600" b="0">
+              <a:t> (não 0,70): queries em inglês têm BM25=0 → score = 0,85 × semântico (ainda alto)</a:t>
+            </a:r>
+          </a:p>
+          <a:p>
+            <a:pPr/>
+            <a:r>
+              <a:rPr sz="1700" b="1">
                 <a:solidFill>
                   <a:srgbClr val="2C3E50"/>
                 </a:solidFill>
               </a:rPr>
-              <a:t>Economiza quota de API · bloqueia perguntas fora do domínio automaticamente</a:t>
-            </a:r>
-          </a:p>
-          <a:p>
-            <a:pPr>
-              <a:spcBef>
-                <a:spcPts val="400"/>
-              </a:spcBef>
-            </a:pPr>
-          </a:p>
-          <a:p>
-            <a:pPr/>
-            <a:r>
-              <a:rPr sz="1700" b="1">
+              <a:t>top-k = 6</a:t>
+            </a:r>
+            <a:r>
+              <a:rPr sz="1700" b="0">
                 <a:solidFill>
                   <a:srgbClr val="2C3E50"/>
                 </a:solidFill>
               </a:rPr>
-              <a:t>top-k = 4</a:t>
-            </a:r>
-            <a:r>
-              <a:rPr sz="1700" b="0">
-                <a:solidFill>
-                  <a:srgbClr val="2C3E50"/>
-                </a:solidFill>
-              </a:rPr>
-              <a:t> por padrão (slider de 2 a 8 no Streamlit)</a:t>
-            </a:r>
-          </a:p>
-          <a:p>
-            <a:pPr lvl="1"/>
-            <a:r>
-              <a:rPr sz="1600" b="0">
-                <a:solidFill>
-                  <a:srgbClr val="2C3E50"/>
-                </a:solidFill>
-              </a:rPr>
-              <a:t>top-k=8 melhora cobertura para 75% com latência similar</a:t>
-            </a:r>
-          </a:p>
-          <a:p>
-            <a:pPr>
-              <a:spcBef>
-                <a:spcPts val="400"/>
-              </a:spcBef>
-            </a:pPr>
-          </a:p>
-          <a:p>
-            <a:pPr/>
-            <a:r>
-              <a:rPr sz="1700" b="0">
-                <a:solidFill>
-                  <a:srgbClr val="2C3E50"/>
-                </a:solidFill>
-              </a:rPr>
-              <a:t>Cada match retorna: texto · score · documento · página · artigo detectado</a:t>
+              <a:t> padrão · slider 2-12 no Streamlit · cada match retorna texto, score, fonte, artigo</a:t>
             </a:r>
           </a:p>
         </p:txBody>

</xml_diff>